<commit_message>
3-1 slide 25: add LOCAL/ENGINEERING REVISION feedback paths to method diagram
Align with 3-0 kickoff slide 4 grammar: gold (8E6F3E) Evidence->Model
vertical line (ENGINEERING REVISION) + grey (555960) custGeom U-route
Evidence->Realize (LOCAL REVISION), both 20pt labels in the inter-row
band. Engineering label tail shortened one word to fit the 0.80in band
at 20pt in two lines.

Co-Authored-By: Claude Opus 5 <noreply@anthropic.com>
</commit_message>
<xml_diff>
--- a/course/lectures/act-3-software-in-the-world/01-compute-environments-and-deployment/3-1-Compute-Environments-and-Deployment.pptx
+++ b/course/lectures/act-3-software-in-the-world/01-compute-environments-and-deployment/3-1-Compute-Environments-and-Deployment.pptx
@@ -19024,6 +19024,172 @@
           </a:fontRef>
         </p:style>
       </p:cxnSp>
+      <p:cxnSp>
+        <p:nvCxnSpPr>
+          <p:cNvPr id="3550" name="Engineering revision path"/>
+          <p:cNvCxnSpPr/>
+          <p:nvPr/>
+        </p:nvCxnSpPr>
+        <p:spPr>
+          <a:xfrm flipV="1">
+            <a:off x="4069080" y="2377440"/>
+            <a:ext cx="0" cy="731520"/>
+          </a:xfrm>
+          <a:prstGeom prst="line">
+            <a:avLst/>
+          </a:prstGeom>
+          <a:ln w="19050">
+            <a:solidFill>
+              <a:srgbClr val="8E6F3E"/>
+            </a:solidFill>
+            <a:tailEnd type="triangle"/>
+          </a:ln>
+        </p:spPr>
+        <p:style>
+          <a:lnRef idx="2">
+            <a:schemeClr val="accent1"/>
+          </a:lnRef>
+          <a:fillRef idx="0">
+            <a:schemeClr val="accent1"/>
+          </a:fillRef>
+          <a:effectRef idx="1">
+            <a:schemeClr val="accent1"/>
+          </a:effectRef>
+          <a:fontRef idx="minor">
+            <a:schemeClr val="tx1"/>
+          </a:fontRef>
+        </p:style>
+      </p:cxnSp>
+      <p:sp>
+        <p:nvSpPr>
+          <p:cNvPr id="3551" name="Local revision path"/>
+          <p:cNvSpPr/>
+          <p:nvPr/>
+        </p:nvSpPr>
+        <p:spPr>
+          <a:xfrm>
+            <a:off x="5349240" y="2761488"/>
+            <a:ext cx="1737360" cy="347472"/>
+          </a:xfrm>
+          <a:custGeom>
+            <a:avLst/>
+            <a:gdLst/>
+            <a:ahLst/>
+            <a:cxnLst/>
+            <a:pathLst>
+              <a:path w="1737360" h="347472" fill="none">
+                <a:moveTo>
+                  <a:pt x="0" y="347472"/>
+                </a:moveTo>
+                <a:lnTo>
+                  <a:pt x="0" y="0"/>
+                </a:lnTo>
+                <a:lnTo>
+                  <a:pt x="1737360" y="0"/>
+                </a:lnTo>
+                <a:lnTo>
+                  <a:pt x="1737360" y="347472"/>
+                </a:lnTo>
+              </a:path>
+            </a:pathLst>
+          </a:custGeom>
+          <a:noFill/>
+          <a:ln w="19050">
+            <a:solidFill>
+              <a:srgbClr val="555960"/>
+            </a:solidFill>
+            <a:tailEnd type="triangle"/>
+          </a:ln>
+        </p:spPr>
+        <p:txBody>
+          <a:bodyPr wrap="square" rtlCol="0"/>
+          <a:lstStyle/>
+          <a:p/>
+        </p:txBody>
+      </p:sp>
+      <p:sp>
+        <p:nvSpPr>
+          <p:cNvPr id="3552" name="Engineering revision label"/>
+          <p:cNvSpPr/>
+          <p:nvPr/>
+        </p:nvSpPr>
+        <p:spPr>
+          <a:xfrm>
+            <a:off x="365760" y="2395728"/>
+            <a:ext cx="3566160" cy="694944"/>
+          </a:xfrm>
+          <a:prstGeom prst="rect">
+            <a:avLst/>
+          </a:prstGeom>
+          <a:noFill/>
+          <a:ln>
+            <a:noFill/>
+          </a:ln>
+          <a:effectLst/>
+        </p:spPr>
+        <p:txBody>
+          <a:bodyPr wrap="square" lIns="27432" tIns="11430" rIns="27432" bIns="11430" rtlCol="0" anchor="ctr"/>
+          <a:lstStyle/>
+          <a:p>
+            <a:pPr algn="r"/>
+            <a:r>
+              <a:rPr sz="2000" b="1" i="0" dirty="0">
+                <a:solidFill>
+                  <a:srgbClr val="8E6F3E"/>
+                </a:solidFill>
+              </a:rPr>
+              <a:t>ENGINEERING REVISION:</a:t>
+            </a:r>
+          </a:p>
+          <a:p>
+            <a:pPr algn="r"/>
+            <a:r>
+              <a:rPr sz="2000" b="1" i="0" dirty="0">
+                <a:solidFill>
+                  <a:srgbClr val="8E6F3E"/>
+                </a:solidFill>
+              </a:rPr>
+              <a:t>rethink the model or judgment</a:t>
+            </a:r>
+          </a:p>
+        </p:txBody>
+      </p:sp>
+      <p:sp>
+        <p:nvSpPr>
+          <p:cNvPr id="3553" name="Local revision label"/>
+          <p:cNvSpPr/>
+          <p:nvPr/>
+        </p:nvSpPr>
+        <p:spPr>
+          <a:xfrm>
+            <a:off x="4526280" y="2395728"/>
+            <a:ext cx="4069080" cy="347472"/>
+          </a:xfrm>
+          <a:prstGeom prst="rect">
+            <a:avLst/>
+          </a:prstGeom>
+          <a:noFill/>
+          <a:ln>
+            <a:noFill/>
+          </a:ln>
+          <a:effectLst/>
+        </p:spPr>
+        <p:txBody>
+          <a:bodyPr wrap="square" lIns="27432" tIns="11430" rIns="27432" bIns="11430" rtlCol="0" anchor="ctr"/>
+          <a:lstStyle/>
+          <a:p>
+            <a:pPr algn="ctr"/>
+            <a:r>
+              <a:rPr sz="2000" b="1" i="0" dirty="0">
+                <a:solidFill>
+                  <a:srgbClr val="555960"/>
+                </a:solidFill>
+              </a:rPr>
+              <a:t>LOCAL REVISION: fix the realization</a:t>
+            </a:r>
+          </a:p>
+        </p:txBody>
+      </p:sp>
     </p:spTree>
   </p:cSld>
   <p:clrMapOvr>

</xml_diff>